<commit_message>
docs: update PPTX — mandatory self-host hardware, all cloud-first → in-house AI
- Slide 2: break-even ~Y3Q3 → ~Year 5
- Slide 3: Model A break-even Y2Q4 → Y3Q4, cloud-first → in-house AI
- Slide 4: Model A nets -2,180K/+20K/+3,475K → -3,625K/+565K/+4,000K
- Slide 6: cloud-first → in-house AI from Y1 (EGPC mandate)
- Slide 8: Model B costs/nets all updated (max Y1 cost 1,856K→6,311K)
- Slide 10: base (3,271K)→(8,671K), conservative (10,250K)→(19,250K)
- Slide 11: self-host migration → in-house AI operational, add Y1Q2 hardware
- Slide 12: 3.6M→~5.1M, runpod migration → Dell R760xa + 4× A100 Y1Q2

Co-Authored-By: Claude Opus 4.7 <noreply@anthropic.com>
</commit_message>
<xml_diff>
--- a/ESE_Business_Model_v2.pptx
+++ b/ESE_Business_Model_v2.pptx
@@ -3490,7 +3490,7 @@
               </a:defRPr>
             </a:pPr>
             <a:r>
-              <a:t>(10,250K)</a:t>
+              <a:t>(19,250K)</a:t>
             </a:r>
           </a:p>
           <a:p>
@@ -3506,7 +3506,7 @@
             </a:r>
             <a:br/>
             <a:r>
-              <a:t>Slow self-host</a:t>
+              <a:t>Slow adoption</a:t>
             </a:r>
             <a:br/>
             <a:r>
@@ -3576,7 +3576,7 @@
               </a:defRPr>
             </a:pPr>
             <a:r>
-              <a:t>(3,271K)</a:t>
+              <a:t>(8,671K)</a:t>
             </a:r>
           </a:p>
           <a:p>
@@ -3592,11 +3592,11 @@
             </a:r>
             <a:br/>
             <a:r>
-              <a:t>Break-even: Y3Q3</a:t>
+              <a:t>Break-even: ~Y5</a:t>
             </a:r>
             <a:br/>
             <a:r>
-              <a:t>Combined strategy</a:t>
+              <a:t>In-house AI Day 1</a:t>
             </a:r>
           </a:p>
         </p:txBody>
@@ -3662,7 +3662,7 @@
               </a:defRPr>
             </a:pPr>
             <a:r>
-              <a:t>+10,850K</a:t>
+              <a:t>+11,850K</a:t>
             </a:r>
           </a:p>
           <a:p>
@@ -3961,7 +3961,7 @@
               </a:defRPr>
             </a:pPr>
             <a:r>
-              <a:t>v2 soft launch. 40 paying. SPE Egypt webinar.</a:t>
+              <a:t>Hardware procurement. Hardware procurement. v2 soft launch. 40 paying. SPE Egypt webinar.</a:t>
             </a:r>
           </a:p>
         </p:txBody>
@@ -4241,7 +4241,7 @@
               </a:defRPr>
             </a:pPr>
             <a:r>
-              <a:t>Self-host migration (RunPod). 450 paying. 5 B companies.</a:t>
+              <a:t>In-house AI operational. 450 paying. 5 B companies.</a:t>
             </a:r>
           </a:p>
         </p:txBody>
@@ -4628,7 +4628,7 @@
               </a:defRPr>
             </a:pPr>
             <a:r>
-              <a:t>1. Metwally approval: Two-track strategy + 3.6M EGP initial investment</a:t>
+              <a:t>1. Metwally approval: Two-track strategy + ~5.1M EGP initial investment</a:t>
             </a:r>
           </a:p>
           <a:p>
@@ -4733,7 +4733,7 @@
               </a:defRPr>
             </a:pPr>
             <a:r>
-              <a:t>8. Self-host migration planning (RunPod Qwen3-32B, Y2Q2 trigger)</a:t>
+              <a:t>8. In-house AI deployment (Dell R760xa + 4× A100, Y1Q2 delivery)</a:t>
             </a:r>
           </a:p>
         </p:txBody>
@@ -4990,7 +4990,7 @@
               </a:defRPr>
             </a:pPr>
             <a:r>
-              <a:t>Combined 3-year revenue: 17.2M EGP. Combined break-even: ~Y3Q3.</a:t>
+              <a:t>Combined 3-year revenue: 17.2M EGP. Combined break-even: ~Year 5.</a:t>
             </a:r>
           </a:p>
           <a:p>
@@ -5261,7 +5261,7 @@
               </a:defRPr>
             </a:pPr>
             <a:r>
-              <a:t>~Y3Q3</a:t>
+              <a:t>~Year 5</a:t>
             </a:r>
           </a:p>
           <a:p>
@@ -5528,7 +5528,7 @@
               </a:defRPr>
             </a:pPr>
             <a:r>
-              <a:t>  Break-even: Y2Q4</a:t>
+              <a:t>  Break-even: Y3Q4</a:t>
             </a:r>
           </a:p>
           <a:p>
@@ -5730,7 +5730,7 @@
               </a:defRPr>
             </a:pPr>
             <a:r>
-              <a:t>  Cloud-first, lean team (2-5 FTE)</a:t>
+              <a:t>  In-house AI from Y1 (EGPC mandate)</a:t>
             </a:r>
           </a:p>
         </p:txBody>
@@ -6391,7 +6391,7 @@
               </a:defRPr>
             </a:pPr>
             <a:r>
-              <a:t>Y1: 150 users  |  650K rev  |  -2,180K net</a:t>
+              <a:t>Y1: 150 users  |  650K rev  |  -3,625K net</a:t>
             </a:r>
           </a:p>
         </p:txBody>
@@ -6426,7 +6426,7 @@
               </a:defRPr>
             </a:pPr>
             <a:r>
-              <a:t>Y2: 900 users  |  4,300K rev  |  +20K net (break-even)</a:t>
+              <a:t>Y2: 900 users  |  4,300K rev  |  +565K net</a:t>
             </a:r>
           </a:p>
         </p:txBody>
@@ -6461,7 +6461,7 @@
               </a:defRPr>
             </a:pPr>
             <a:r>
-              <a:t>Y3: 2,400 users  |  8,800K rev  |  +3,475K net</a:t>
+              <a:t>Y3: 2,400 users  |  8,800K rev  |  +4,000K net</a:t>
             </a:r>
           </a:p>
         </p:txBody>
@@ -7804,7 +7804,7 @@
               </a:defRPr>
             </a:pPr>
             <a:r>
-              <a:t>Target: 10 EGPC Subsidiaries  |  Steady-state TAM: ~1.7-1.85M EGP/yr  |  Cloud-first, lean team (2-5 FTE)</a:t>
+              <a:t>Target: 10 EGPC Subsidiaries  |  Steady-state TAM: ~1.7-1.85M EGP/yr  |  In-house AI from Y1 (EGPC mandate)</a:t>
             </a:r>
           </a:p>
         </p:txBody>
@@ -8360,7 +8360,7 @@
               </a:defRPr>
             </a:pPr>
             <a:r>
-              <a:t>Model B — Financials (Lean, Cloud-First)</a:t>
+              <a:t>Model B — Financials (In-House AI, EGPC-Compliant)</a:t>
             </a:r>
           </a:p>
         </p:txBody>
@@ -8459,7 +8459,7 @@
             </a:r>
             <a:br/>
             <a:r>
-              <a:t>(pilots)  |  Revenue: 75K rev  |  Costs: 1,856K cost  |  Net: -1,781K net</a:t>
+              <a:t>(pilots)  |  Revenue: 75K rev  |  Costs: 6,311K cost  |  Net: -6,236K net</a:t>
             </a:r>
           </a:p>
           <a:p>
@@ -8523,7 +8523,7 @@
               </a:defRPr>
             </a:pPr>
             <a:r>
-              <a:t>Y2: 7 companies  |  Revenue: 1,150K rev  |  Costs: 2,520K cost  |  Net: -1,370K net</a:t>
+              <a:t>Y2: 7 companies  |  Revenue: 1,150K rev  |  Costs: 2,855K cost  |  Net: -1,705K net</a:t>
             </a:r>
           </a:p>
           <a:p>
@@ -8587,7 +8587,7 @@
               </a:defRPr>
             </a:pPr>
             <a:r>
-              <a:t>Y3: 10 companies  |  Revenue: 2,250K rev  |  Costs: 3,685K cost  |  Net: -1,435K net</a:t>
+              <a:t>Y3: 10 companies  |  Revenue: 2,250K rev  |  Costs: 3,920K cost  |  Net: -1,670K net</a:t>
             </a:r>
           </a:p>
           <a:p>

</xml_diff>